<commit_message>
Update investor deck presentation and visual styling
Adjusted PDF/PPTX export settings, updated HTML styling with new color variables, and modified viewport dimensions for the investor deck.

Replit-Commit-Author: Agent
Replit-Commit-Session-Id: f31b7069-9dc7-4365-be20-0c8157137ea2
Replit-Commit-Checkpoint-Type: full_checkpoint
Replit-Commit-Event-Id: 67140045-6df5-480e-9178-9c4771c95830
Replit-Commit-Screenshot-Url: https://storage.googleapis.com/screenshot-production-us-central1/e56cd826-6031-480e-8c02-ef3bd7b48c68/f31b7069-9dc7-4365-be20-0c8157137ea2/IF2oJut
Replit-Helium-Checkpoint-Created: true
</commit_message>
<xml_diff>
--- a/investor-materials/GUBER-Investor-Deck.pptx
+++ b/investor-materials/GUBER-Investor-Deck.pptx
@@ -20,6 +20,11 @@
     <p:sldId id="268" r:id="rId19"/>
     <p:sldId id="269" r:id="rId20"/>
     <p:sldId id="270" r:id="rId21"/>
+    <p:sldId id="271" r:id="rId22"/>
+    <p:sldId id="272" r:id="rId23"/>
+    <p:sldId id="273" r:id="rId24"/>
+    <p:sldId id="274" r:id="rId25"/>
+    <p:sldId id="275" r:id="rId26"/>
   </p:sldIdLst>
   <p:sldSz cx="12191695" cy="6858000" type="screen4x3"/>
   <p:notesSz cx="6858000" cy="9144000"/>
@@ -3386,6 +3391,174 @@
 </p:sld>
 </file>
 
+<file path=ppt/slides/slide16.xml><?xml version="1.0" encoding="utf-8"?>
+<p:sld xmlns:a="http://schemas.openxmlformats.org/drawingml/2006/main" xmlns:p="http://schemas.openxmlformats.org/presentationml/2006/main" xmlns:r="http://schemas.openxmlformats.org/officeDocument/2006/relationships">
+  <p:cSld>
+    <p:spTree>
+      <p:nvGrpSpPr>
+        <p:cNvPr id="1" name=""/>
+        <p:cNvGrpSpPr/>
+        <p:nvPr/>
+      </p:nvGrpSpPr>
+      <p:grpSpPr/>
+      <p:pic>
+        <p:nvPicPr>
+          <p:cNvPr id="2" name="Picture 1" descr="slide-16.png"/>
+          <p:cNvPicPr>
+            <a:picLocks noChangeAspect="1"/>
+          </p:cNvPicPr>
+          <p:nvPr/>
+        </p:nvPicPr>
+        <p:blipFill>
+          <a:blip r:embed="rId2"/>
+          <a:stretch>
+            <a:fillRect/>
+          </a:stretch>
+        </p:blipFill>
+        <p:spPr>
+          <a:xfrm>
+            <a:off x="0" y="0"/>
+            <a:ext cx="12191695" cy="6858000"/>
+          </a:xfrm>
+          <a:prstGeom prst="rect">
+            <a:avLst/>
+          </a:prstGeom>
+        </p:spPr>
+      </p:pic>
+    </p:spTree>
+  </p:cSld>
+  <p:clrMapOvr>
+    <a:masterClrMapping/>
+  </p:clrMapOvr>
+</p:sld>
+</file>
+
+<file path=ppt/slides/slide17.xml><?xml version="1.0" encoding="utf-8"?>
+<p:sld xmlns:a="http://schemas.openxmlformats.org/drawingml/2006/main" xmlns:p="http://schemas.openxmlformats.org/presentationml/2006/main" xmlns:r="http://schemas.openxmlformats.org/officeDocument/2006/relationships">
+  <p:cSld>
+    <p:spTree>
+      <p:nvGrpSpPr>
+        <p:cNvPr id="1" name=""/>
+        <p:cNvGrpSpPr/>
+        <p:nvPr/>
+      </p:nvGrpSpPr>
+      <p:grpSpPr/>
+      <p:pic>
+        <p:nvPicPr>
+          <p:cNvPr id="2" name="Picture 1" descr="slide-17.png"/>
+          <p:cNvPicPr>
+            <a:picLocks noChangeAspect="1"/>
+          </p:cNvPicPr>
+          <p:nvPr/>
+        </p:nvPicPr>
+        <p:blipFill>
+          <a:blip r:embed="rId2"/>
+          <a:stretch>
+            <a:fillRect/>
+          </a:stretch>
+        </p:blipFill>
+        <p:spPr>
+          <a:xfrm>
+            <a:off x="0" y="0"/>
+            <a:ext cx="12191695" cy="6858000"/>
+          </a:xfrm>
+          <a:prstGeom prst="rect">
+            <a:avLst/>
+          </a:prstGeom>
+        </p:spPr>
+      </p:pic>
+    </p:spTree>
+  </p:cSld>
+  <p:clrMapOvr>
+    <a:masterClrMapping/>
+  </p:clrMapOvr>
+</p:sld>
+</file>
+
+<file path=ppt/slides/slide18.xml><?xml version="1.0" encoding="utf-8"?>
+<p:sld xmlns:a="http://schemas.openxmlformats.org/drawingml/2006/main" xmlns:p="http://schemas.openxmlformats.org/presentationml/2006/main" xmlns:r="http://schemas.openxmlformats.org/officeDocument/2006/relationships">
+  <p:cSld>
+    <p:spTree>
+      <p:nvGrpSpPr>
+        <p:cNvPr id="1" name=""/>
+        <p:cNvGrpSpPr/>
+        <p:nvPr/>
+      </p:nvGrpSpPr>
+      <p:grpSpPr/>
+      <p:pic>
+        <p:nvPicPr>
+          <p:cNvPr id="2" name="Picture 1" descr="slide-18.png"/>
+          <p:cNvPicPr>
+            <a:picLocks noChangeAspect="1"/>
+          </p:cNvPicPr>
+          <p:nvPr/>
+        </p:nvPicPr>
+        <p:blipFill>
+          <a:blip r:embed="rId2"/>
+          <a:stretch>
+            <a:fillRect/>
+          </a:stretch>
+        </p:blipFill>
+        <p:spPr>
+          <a:xfrm>
+            <a:off x="0" y="0"/>
+            <a:ext cx="12191695" cy="6858000"/>
+          </a:xfrm>
+          <a:prstGeom prst="rect">
+            <a:avLst/>
+          </a:prstGeom>
+        </p:spPr>
+      </p:pic>
+    </p:spTree>
+  </p:cSld>
+  <p:clrMapOvr>
+    <a:masterClrMapping/>
+  </p:clrMapOvr>
+</p:sld>
+</file>
+
+<file path=ppt/slides/slide19.xml><?xml version="1.0" encoding="utf-8"?>
+<p:sld xmlns:a="http://schemas.openxmlformats.org/drawingml/2006/main" xmlns:p="http://schemas.openxmlformats.org/presentationml/2006/main" xmlns:r="http://schemas.openxmlformats.org/officeDocument/2006/relationships">
+  <p:cSld>
+    <p:spTree>
+      <p:nvGrpSpPr>
+        <p:cNvPr id="1" name=""/>
+        <p:cNvGrpSpPr/>
+        <p:nvPr/>
+      </p:nvGrpSpPr>
+      <p:grpSpPr/>
+      <p:pic>
+        <p:nvPicPr>
+          <p:cNvPr id="2" name="Picture 1" descr="slide-19.png"/>
+          <p:cNvPicPr>
+            <a:picLocks noChangeAspect="1"/>
+          </p:cNvPicPr>
+          <p:nvPr/>
+        </p:nvPicPr>
+        <p:blipFill>
+          <a:blip r:embed="rId2"/>
+          <a:stretch>
+            <a:fillRect/>
+          </a:stretch>
+        </p:blipFill>
+        <p:spPr>
+          <a:xfrm>
+            <a:off x="0" y="0"/>
+            <a:ext cx="12191695" cy="6858000"/>
+          </a:xfrm>
+          <a:prstGeom prst="rect">
+            <a:avLst/>
+          </a:prstGeom>
+        </p:spPr>
+      </p:pic>
+    </p:spTree>
+  </p:cSld>
+  <p:clrMapOvr>
+    <a:masterClrMapping/>
+  </p:clrMapOvr>
+</p:sld>
+</file>
+
 <file path=ppt/slides/slide2.xml><?xml version="1.0" encoding="utf-8"?>
 <p:sld xmlns:a="http://schemas.openxmlformats.org/drawingml/2006/main" xmlns:p="http://schemas.openxmlformats.org/presentationml/2006/main" xmlns:r="http://schemas.openxmlformats.org/officeDocument/2006/relationships">
   <p:cSld>
@@ -3399,6 +3572,48 @@
       <p:pic>
         <p:nvPicPr>
           <p:cNvPr id="2" name="Picture 1" descr="slide-02.png"/>
+          <p:cNvPicPr>
+            <a:picLocks noChangeAspect="1"/>
+          </p:cNvPicPr>
+          <p:nvPr/>
+        </p:nvPicPr>
+        <p:blipFill>
+          <a:blip r:embed="rId2"/>
+          <a:stretch>
+            <a:fillRect/>
+          </a:stretch>
+        </p:blipFill>
+        <p:spPr>
+          <a:xfrm>
+            <a:off x="0" y="0"/>
+            <a:ext cx="12191695" cy="6858000"/>
+          </a:xfrm>
+          <a:prstGeom prst="rect">
+            <a:avLst/>
+          </a:prstGeom>
+        </p:spPr>
+      </p:pic>
+    </p:spTree>
+  </p:cSld>
+  <p:clrMapOvr>
+    <a:masterClrMapping/>
+  </p:clrMapOvr>
+</p:sld>
+</file>
+
+<file path=ppt/slides/slide20.xml><?xml version="1.0" encoding="utf-8"?>
+<p:sld xmlns:a="http://schemas.openxmlformats.org/drawingml/2006/main" xmlns:p="http://schemas.openxmlformats.org/presentationml/2006/main" xmlns:r="http://schemas.openxmlformats.org/officeDocument/2006/relationships">
+  <p:cSld>
+    <p:spTree>
+      <p:nvGrpSpPr>
+        <p:cNvPr id="1" name=""/>
+        <p:cNvGrpSpPr/>
+        <p:nvPr/>
+      </p:nvGrpSpPr>
+      <p:grpSpPr/>
+      <p:pic>
+        <p:nvPicPr>
+          <p:cNvPr id="2" name="Picture 1" descr="slide-20.png"/>
           <p:cNvPicPr>
             <a:picLocks noChangeAspect="1"/>
           </p:cNvPicPr>

</xml_diff>

<commit_message>
Update investor materials with new branding and content
Update investor deck (PDF and PPTX) with new branding, including logo, mascot, and updated slide content. Add new Founder slide and renumber all pages to 22. Update cover and closing slides with the official GUBER logo. Replace various placeholder images with final assets.

Replit-Commit-Author: Agent
Replit-Commit-Session-Id: f31b7069-9dc7-4365-be20-0c8157137ea2
Replit-Commit-Checkpoint-Type: full_checkpoint
Replit-Commit-Event-Id: cc6ae7ff-492f-46bc-bb96-fd9990a81f44
Replit-Commit-Screenshot-Url: https://storage.googleapis.com/screenshot-production-us-central1/e56cd826-6031-480e-8c02-ef3bd7b48c68/f31b7069-9dc7-4365-be20-0c8157137ea2/IF2oJut
Replit-Helium-Checkpoint-Created: true
</commit_message>
<xml_diff>
--- a/investor-materials/GUBER-Investor-Deck.pptx
+++ b/investor-materials/GUBER-Investor-Deck.pptx
@@ -25,6 +25,8 @@
     <p:sldId id="273" r:id="rId24"/>
     <p:sldId id="274" r:id="rId25"/>
     <p:sldId id="275" r:id="rId26"/>
+    <p:sldId id="276" r:id="rId27"/>
+    <p:sldId id="277" r:id="rId28"/>
   </p:sldIdLst>
   <p:sldSz cx="12191695" cy="6858000" type="screen4x3"/>
   <p:notesSz cx="6858000" cy="9144000"/>
@@ -3614,6 +3616,90 @@
       <p:pic>
         <p:nvPicPr>
           <p:cNvPr id="2" name="Picture 1" descr="slide-20.png"/>
+          <p:cNvPicPr>
+            <a:picLocks noChangeAspect="1"/>
+          </p:cNvPicPr>
+          <p:nvPr/>
+        </p:nvPicPr>
+        <p:blipFill>
+          <a:blip r:embed="rId2"/>
+          <a:stretch>
+            <a:fillRect/>
+          </a:stretch>
+        </p:blipFill>
+        <p:spPr>
+          <a:xfrm>
+            <a:off x="0" y="0"/>
+            <a:ext cx="12191695" cy="6858000"/>
+          </a:xfrm>
+          <a:prstGeom prst="rect">
+            <a:avLst/>
+          </a:prstGeom>
+        </p:spPr>
+      </p:pic>
+    </p:spTree>
+  </p:cSld>
+  <p:clrMapOvr>
+    <a:masterClrMapping/>
+  </p:clrMapOvr>
+</p:sld>
+</file>
+
+<file path=ppt/slides/slide21.xml><?xml version="1.0" encoding="utf-8"?>
+<p:sld xmlns:a="http://schemas.openxmlformats.org/drawingml/2006/main" xmlns:p="http://schemas.openxmlformats.org/presentationml/2006/main" xmlns:r="http://schemas.openxmlformats.org/officeDocument/2006/relationships">
+  <p:cSld>
+    <p:spTree>
+      <p:nvGrpSpPr>
+        <p:cNvPr id="1" name=""/>
+        <p:cNvGrpSpPr/>
+        <p:nvPr/>
+      </p:nvGrpSpPr>
+      <p:grpSpPr/>
+      <p:pic>
+        <p:nvPicPr>
+          <p:cNvPr id="2" name="Picture 1" descr="slide-21.png"/>
+          <p:cNvPicPr>
+            <a:picLocks noChangeAspect="1"/>
+          </p:cNvPicPr>
+          <p:nvPr/>
+        </p:nvPicPr>
+        <p:blipFill>
+          <a:blip r:embed="rId2"/>
+          <a:stretch>
+            <a:fillRect/>
+          </a:stretch>
+        </p:blipFill>
+        <p:spPr>
+          <a:xfrm>
+            <a:off x="0" y="0"/>
+            <a:ext cx="12191695" cy="6858000"/>
+          </a:xfrm>
+          <a:prstGeom prst="rect">
+            <a:avLst/>
+          </a:prstGeom>
+        </p:spPr>
+      </p:pic>
+    </p:spTree>
+  </p:cSld>
+  <p:clrMapOvr>
+    <a:masterClrMapping/>
+  </p:clrMapOvr>
+</p:sld>
+</file>
+
+<file path=ppt/slides/slide22.xml><?xml version="1.0" encoding="utf-8"?>
+<p:sld xmlns:a="http://schemas.openxmlformats.org/drawingml/2006/main" xmlns:p="http://schemas.openxmlformats.org/presentationml/2006/main" xmlns:r="http://schemas.openxmlformats.org/officeDocument/2006/relationships">
+  <p:cSld>
+    <p:spTree>
+      <p:nvGrpSpPr>
+        <p:cNvPr id="1" name=""/>
+        <p:cNvGrpSpPr/>
+        <p:nvPr/>
+      </p:nvGrpSpPr>
+      <p:grpSpPr/>
+      <p:pic>
+        <p:nvPicPr>
+          <p:cNvPr id="2" name="Picture 1" descr="slide-22.png"/>
           <p:cNvPicPr>
             <a:picLocks noChangeAspect="1"/>
           </p:cNvPicPr>

</xml_diff>

<commit_message>
Update founder information and presentation details
Update founder name to Dimetris Bowden, relocate to Greensboro, NC, change investor email to investors@guberapp.com, and adjust presentation slide formatting for better display.

Replit-Commit-Author: Agent
Replit-Commit-Session-Id: f31b7069-9dc7-4365-be20-0c8157137ea2
Replit-Commit-Checkpoint-Type: full_checkpoint
Replit-Commit-Event-Id: 042af841-fcaf-42be-991f-fda97e67e339
Replit-Commit-Screenshot-Url: https://storage.googleapis.com/screenshot-production-us-central1/e56cd826-6031-480e-8c02-ef3bd7b48c68/f31b7069-9dc7-4365-be20-0c8157137ea2/IF2oJut
Replit-Helium-Checkpoint-Created: true
</commit_message>
<xml_diff>
--- a/investor-materials/GUBER-Investor-Deck.pptx
+++ b/investor-materials/GUBER-Investor-Deck.pptx
@@ -28,7 +28,7 @@
     <p:sldId id="276" r:id="rId27"/>
     <p:sldId id="277" r:id="rId28"/>
   </p:sldIdLst>
-  <p:sldSz cx="12191695" cy="6858000" type="screen4x3"/>
+  <p:sldSz cx="12192000" cy="6858000" type="screen4x3"/>
   <p:notesSz cx="6858000" cy="9144000"/>
   <p:defaultTextStyle>
     <a:defPPr>
@@ -3126,7 +3126,7 @@
         <p:spPr>
           <a:xfrm>
             <a:off x="0" y="0"/>
-            <a:ext cx="12191695" cy="6858000"/>
+            <a:ext cx="12192000" cy="6858000"/>
           </a:xfrm>
           <a:prstGeom prst="rect">
             <a:avLst/>
@@ -3168,7 +3168,7 @@
         <p:spPr>
           <a:xfrm>
             <a:off x="0" y="0"/>
-            <a:ext cx="12191695" cy="6858000"/>
+            <a:ext cx="12192000" cy="6858000"/>
           </a:xfrm>
           <a:prstGeom prst="rect">
             <a:avLst/>
@@ -3210,7 +3210,7 @@
         <p:spPr>
           <a:xfrm>
             <a:off x="0" y="0"/>
-            <a:ext cx="12191695" cy="6858000"/>
+            <a:ext cx="12192000" cy="6858000"/>
           </a:xfrm>
           <a:prstGeom prst="rect">
             <a:avLst/>
@@ -3252,7 +3252,7 @@
         <p:spPr>
           <a:xfrm>
             <a:off x="0" y="0"/>
-            <a:ext cx="12191695" cy="6858000"/>
+            <a:ext cx="12192000" cy="6858000"/>
           </a:xfrm>
           <a:prstGeom prst="rect">
             <a:avLst/>
@@ -3294,7 +3294,7 @@
         <p:spPr>
           <a:xfrm>
             <a:off x="0" y="0"/>
-            <a:ext cx="12191695" cy="6858000"/>
+            <a:ext cx="12192000" cy="6858000"/>
           </a:xfrm>
           <a:prstGeom prst="rect">
             <a:avLst/>
@@ -3336,7 +3336,7 @@
         <p:spPr>
           <a:xfrm>
             <a:off x="0" y="0"/>
-            <a:ext cx="12191695" cy="6858000"/>
+            <a:ext cx="12192000" cy="6858000"/>
           </a:xfrm>
           <a:prstGeom prst="rect">
             <a:avLst/>
@@ -3378,7 +3378,7 @@
         <p:spPr>
           <a:xfrm>
             <a:off x="0" y="0"/>
-            <a:ext cx="12191695" cy="6858000"/>
+            <a:ext cx="12192000" cy="6858000"/>
           </a:xfrm>
           <a:prstGeom prst="rect">
             <a:avLst/>
@@ -3420,7 +3420,7 @@
         <p:spPr>
           <a:xfrm>
             <a:off x="0" y="0"/>
-            <a:ext cx="12191695" cy="6858000"/>
+            <a:ext cx="12192000" cy="6858000"/>
           </a:xfrm>
           <a:prstGeom prst="rect">
             <a:avLst/>
@@ -3462,7 +3462,7 @@
         <p:spPr>
           <a:xfrm>
             <a:off x="0" y="0"/>
-            <a:ext cx="12191695" cy="6858000"/>
+            <a:ext cx="12192000" cy="6858000"/>
           </a:xfrm>
           <a:prstGeom prst="rect">
             <a:avLst/>
@@ -3504,7 +3504,7 @@
         <p:spPr>
           <a:xfrm>
             <a:off x="0" y="0"/>
-            <a:ext cx="12191695" cy="6858000"/>
+            <a:ext cx="12192000" cy="6858000"/>
           </a:xfrm>
           <a:prstGeom prst="rect">
             <a:avLst/>
@@ -3546,7 +3546,7 @@
         <p:spPr>
           <a:xfrm>
             <a:off x="0" y="0"/>
-            <a:ext cx="12191695" cy="6858000"/>
+            <a:ext cx="12192000" cy="6858000"/>
           </a:xfrm>
           <a:prstGeom prst="rect">
             <a:avLst/>
@@ -3588,7 +3588,7 @@
         <p:spPr>
           <a:xfrm>
             <a:off x="0" y="0"/>
-            <a:ext cx="12191695" cy="6858000"/>
+            <a:ext cx="12192000" cy="6858000"/>
           </a:xfrm>
           <a:prstGeom prst="rect">
             <a:avLst/>
@@ -3630,7 +3630,7 @@
         <p:spPr>
           <a:xfrm>
             <a:off x="0" y="0"/>
-            <a:ext cx="12191695" cy="6858000"/>
+            <a:ext cx="12192000" cy="6858000"/>
           </a:xfrm>
           <a:prstGeom prst="rect">
             <a:avLst/>
@@ -3672,7 +3672,7 @@
         <p:spPr>
           <a:xfrm>
             <a:off x="0" y="0"/>
-            <a:ext cx="12191695" cy="6858000"/>
+            <a:ext cx="12192000" cy="6858000"/>
           </a:xfrm>
           <a:prstGeom prst="rect">
             <a:avLst/>
@@ -3714,7 +3714,7 @@
         <p:spPr>
           <a:xfrm>
             <a:off x="0" y="0"/>
-            <a:ext cx="12191695" cy="6858000"/>
+            <a:ext cx="12192000" cy="6858000"/>
           </a:xfrm>
           <a:prstGeom prst="rect">
             <a:avLst/>
@@ -3756,7 +3756,7 @@
         <p:spPr>
           <a:xfrm>
             <a:off x="0" y="0"/>
-            <a:ext cx="12191695" cy="6858000"/>
+            <a:ext cx="12192000" cy="6858000"/>
           </a:xfrm>
           <a:prstGeom prst="rect">
             <a:avLst/>
@@ -3798,7 +3798,7 @@
         <p:spPr>
           <a:xfrm>
             <a:off x="0" y="0"/>
-            <a:ext cx="12191695" cy="6858000"/>
+            <a:ext cx="12192000" cy="6858000"/>
           </a:xfrm>
           <a:prstGeom prst="rect">
             <a:avLst/>
@@ -3840,7 +3840,7 @@
         <p:spPr>
           <a:xfrm>
             <a:off x="0" y="0"/>
-            <a:ext cx="12191695" cy="6858000"/>
+            <a:ext cx="12192000" cy="6858000"/>
           </a:xfrm>
           <a:prstGeom prst="rect">
             <a:avLst/>
@@ -3882,7 +3882,7 @@
         <p:spPr>
           <a:xfrm>
             <a:off x="0" y="0"/>
-            <a:ext cx="12191695" cy="6858000"/>
+            <a:ext cx="12192000" cy="6858000"/>
           </a:xfrm>
           <a:prstGeom prst="rect">
             <a:avLst/>
@@ -3924,7 +3924,7 @@
         <p:spPr>
           <a:xfrm>
             <a:off x="0" y="0"/>
-            <a:ext cx="12191695" cy="6858000"/>
+            <a:ext cx="12192000" cy="6858000"/>
           </a:xfrm>
           <a:prstGeom prst="rect">
             <a:avLst/>
@@ -3966,7 +3966,7 @@
         <p:spPr>
           <a:xfrm>
             <a:off x="0" y="0"/>
-            <a:ext cx="12191695" cy="6858000"/>
+            <a:ext cx="12192000" cy="6858000"/>
           </a:xfrm>
           <a:prstGeom prst="rect">
             <a:avLst/>
@@ -4008,7 +4008,7 @@
         <p:spPr>
           <a:xfrm>
             <a:off x="0" y="0"/>
-            <a:ext cx="12191695" cy="6858000"/>
+            <a:ext cx="12192000" cy="6858000"/>
           </a:xfrm>
           <a:prstGeom prst="rect">
             <a:avLst/>

</xml_diff>